<commit_message>
fix(images): restore missing villi images to public photos and fix paths in digestif page
</commit_message>
<xml_diff>
--- a/fiches/gabarit-evaluation-LCML.pptx
+++ b/fiches/gabarit-evaluation-LCML.pptx
@@ -3390,7 +3390,7 @@
           <a:lstStyle/>
           <a:p>
             <a:pPr algn="ctr">
-              <a:defRPr sz="1200" b="1">
+              <a:defRPr sz="1100" b="1">
                 <a:solidFill>
                   <a:srgbClr val="B16A09"/>
                 </a:solidFill>
@@ -3490,7 +3490,7 @@
           <a:lstStyle/>
           <a:p>
             <a:pPr algn="l">
-              <a:defRPr sz="1400" b="1">
+              <a:defRPr sz="1300" b="1">
                 <a:solidFill>
                   <a:srgbClr val="FFFFFF"/>
                 </a:solidFill>
@@ -3608,7 +3608,7 @@
           <a:lstStyle/>
           <a:p>
             <a:pPr>
-              <a:defRPr sz="1200" i="1" b="1">
+              <a:defRPr sz="1100" i="1" b="1">
                 <a:solidFill>
                   <a:srgbClr val="B16A09"/>
                 </a:solidFill>
@@ -4047,7 +4047,7 @@
           <a:lstStyle/>
           <a:p>
             <a:pPr algn="ctr">
-              <a:defRPr sz="1200" b="1">
+              <a:defRPr sz="1100" b="1">
                 <a:solidFill>
                   <a:srgbClr val="C8102E"/>
                 </a:solidFill>
@@ -4147,7 +4147,7 @@
           <a:lstStyle/>
           <a:p>
             <a:pPr algn="l">
-              <a:defRPr sz="1400" b="1">
+              <a:defRPr sz="1300" b="1">
                 <a:solidFill>
                   <a:srgbClr val="FFFFFF"/>
                 </a:solidFill>
@@ -4265,7 +4265,7 @@
           <a:lstStyle/>
           <a:p>
             <a:pPr>
-              <a:defRPr sz="1200" i="1" b="1">
+              <a:defRPr sz="1100" i="1" b="1">
                 <a:solidFill>
                   <a:srgbClr val="C8102E"/>
                 </a:solidFill>
@@ -4704,7 +4704,7 @@
           <a:lstStyle/>
           <a:p>
             <a:pPr algn="ctr">
-              <a:defRPr sz="1200" b="1">
+              <a:defRPr sz="1100" b="1">
                 <a:solidFill>
                   <a:srgbClr val="2F8457"/>
                 </a:solidFill>
@@ -4804,7 +4804,7 @@
           <a:lstStyle/>
           <a:p>
             <a:pPr algn="l">
-              <a:defRPr sz="1400" b="1">
+              <a:defRPr sz="1300" b="1">
                 <a:solidFill>
                   <a:srgbClr val="FFFFFF"/>
                 </a:solidFill>
@@ -4922,7 +4922,7 @@
           <a:lstStyle/>
           <a:p>
             <a:pPr>
-              <a:defRPr sz="1200" i="1" b="1">
+              <a:defRPr sz="1100" i="1" b="1">
                 <a:solidFill>
                   <a:srgbClr val="2F8457"/>
                 </a:solidFill>

</xml_diff>